<commit_message>
Wykresy i poprawne parametry pod nimi
</commit_message>
<xml_diff>
--- a/ModelAxelroda_prezentacja.pptx
+++ b/ModelAxelroda_prezentacja.pptx
@@ -10,13 +10,15 @@
     <p:sldId id="269" r:id="rId4"/>
     <p:sldId id="261" r:id="rId5"/>
     <p:sldId id="268" r:id="rId6"/>
-    <p:sldId id="259" r:id="rId7"/>
-    <p:sldId id="270" r:id="rId8"/>
-    <p:sldId id="263" r:id="rId9"/>
-    <p:sldId id="265" r:id="rId10"/>
-    <p:sldId id="266" r:id="rId11"/>
-    <p:sldId id="267" r:id="rId12"/>
-    <p:sldId id="264" r:id="rId13"/>
+    <p:sldId id="279" r:id="rId7"/>
+    <p:sldId id="280" r:id="rId8"/>
+    <p:sldId id="281" r:id="rId9"/>
+    <p:sldId id="282" r:id="rId10"/>
+    <p:sldId id="263" r:id="rId11"/>
+    <p:sldId id="278" r:id="rId12"/>
+    <p:sldId id="271" r:id="rId13"/>
+    <p:sldId id="265" r:id="rId14"/>
+    <p:sldId id="264" r:id="rId15"/>
   </p:sldIdLst>
   <p:sldSz cx="12192000" cy="6858000"/>
   <p:notesSz cx="6858000" cy="9144000"/>
@@ -3478,7 +3480,7 @@
         </p:nvSpPr>
         <p:spPr>
           <a:xfrm>
-            <a:off x="1532020" y="4907756"/>
+            <a:off x="1524000" y="4709636"/>
             <a:ext cx="9144000" cy="1655762"/>
           </a:xfrm>
         </p:spPr>
@@ -3577,12 +3579,162 @@
           <a:chExt cx="0" cy="0"/>
         </a:xfrm>
       </p:grpSpPr>
+      <p:sp>
+        <p:nvSpPr>
+          <p:cNvPr id="2" name="Tytuł 1">
+            <a:extLst>
+              <a:ext uri="{FF2B5EF4-FFF2-40B4-BE49-F238E27FC236}">
+                <a16:creationId xmlns:a16="http://schemas.microsoft.com/office/drawing/2014/main" id="{77407CC0-3BB3-4563-A997-6BDBBB130FFE}"/>
+              </a:ext>
+            </a:extLst>
+          </p:cNvPr>
+          <p:cNvSpPr>
+            <a:spLocks noGrp="1"/>
+          </p:cNvSpPr>
+          <p:nvPr>
+            <p:ph type="title"/>
+          </p:nvPr>
+        </p:nvSpPr>
+        <p:spPr/>
+        <p:txBody>
+          <a:bodyPr/>
+          <a:lstStyle/>
+          <a:p>
+            <a:r>
+              <a:rPr lang="pl-PL" dirty="0"/>
+              <a:t>Rozszerzenie modelu</a:t>
+            </a:r>
+            <a:endParaRPr lang="en-US" dirty="0"/>
+          </a:p>
+        </p:txBody>
+      </p:sp>
+      <p:sp>
+        <p:nvSpPr>
+          <p:cNvPr id="3" name="Symbol zastępczy zawartości 2">
+            <a:extLst>
+              <a:ext uri="{FF2B5EF4-FFF2-40B4-BE49-F238E27FC236}">
+                <a16:creationId xmlns:a16="http://schemas.microsoft.com/office/drawing/2014/main" id="{BA4F3297-7DD6-0EF4-82F1-773AB2F43F61}"/>
+              </a:ext>
+            </a:extLst>
+          </p:cNvPr>
+          <p:cNvSpPr>
+            <a:spLocks noGrp="1"/>
+          </p:cNvSpPr>
+          <p:nvPr>
+            <p:ph idx="1"/>
+          </p:nvPr>
+        </p:nvSpPr>
+        <p:spPr>
+          <a:xfrm>
+            <a:off x="838199" y="1825625"/>
+            <a:ext cx="8839201" cy="4222249"/>
+          </a:xfrm>
+        </p:spPr>
+        <p:txBody>
+          <a:bodyPr>
+            <a:normAutofit/>
+          </a:bodyPr>
+          <a:lstStyle/>
+          <a:p>
+            <a:pPr marL="0" indent="0">
+              <a:buNone/>
+            </a:pPr>
+            <a:r>
+              <a:rPr lang="pl-PL" sz="3600" dirty="0"/>
+              <a:t>Wprowadzamy nowe typy sąsiedztw:</a:t>
+            </a:r>
+          </a:p>
+          <a:p>
+            <a:pPr>
+              <a:buFont typeface="Wingdings" panose="05000000000000000000" pitchFamily="2" charset="2"/>
+              <a:buChar char="§"/>
+            </a:pPr>
+            <a:r>
+              <a:rPr lang="pl-PL" sz="3600" dirty="0"/>
+              <a:t>Rozszerzone – zwiększamy sąsiedztwo o przekątne (z 4 wspólnych do 8).</a:t>
+            </a:r>
+          </a:p>
+          <a:p>
+            <a:pPr>
+              <a:buFont typeface="Wingdings" panose="05000000000000000000" pitchFamily="2" charset="2"/>
+              <a:buChar char="§"/>
+            </a:pPr>
+            <a:r>
+              <a:rPr lang="pl-PL" sz="3600" dirty="0"/>
+              <a:t>Toroidalne – łączymy agentów na brzegach (za</a:t>
+            </a:r>
+            <a:r>
+              <a:rPr lang="en-US" sz="3600" dirty="0" err="1"/>
+              <a:t>wijamy</a:t>
+            </a:r>
+            <a:r>
+              <a:rPr lang="en-US" sz="3600" dirty="0"/>
+              <a:t> </a:t>
+            </a:r>
+            <a:r>
+              <a:rPr lang="en-US" sz="3600" dirty="0" err="1"/>
+              <a:t>siatkę</a:t>
+            </a:r>
+            <a:r>
+              <a:rPr lang="en-US" sz="3600" dirty="0"/>
+              <a:t> w </a:t>
+            </a:r>
+            <a:r>
+              <a:rPr lang="en-US" sz="3600" dirty="0" err="1"/>
+              <a:t>kształt</a:t>
+            </a:r>
+            <a:r>
+              <a:rPr lang="en-US" sz="3600" dirty="0"/>
+              <a:t> </a:t>
+            </a:r>
+            <a:r>
+              <a:rPr lang="en-US" sz="3600" dirty="0" err="1"/>
+              <a:t>torusa</a:t>
+            </a:r>
+            <a:r>
+              <a:rPr lang="pl-PL" sz="3600" dirty="0"/>
+              <a:t>), wy</a:t>
+            </a:r>
+            <a:r>
+              <a:rPr lang="en-US" sz="3600" dirty="0" err="1"/>
+              <a:t>równując</a:t>
+            </a:r>
+            <a:r>
+              <a:rPr lang="en-US" sz="3600" dirty="0"/>
+              <a:t> </a:t>
+            </a:r>
+            <a:r>
+              <a:rPr lang="en-US" sz="3600" dirty="0" err="1"/>
+              <a:t>szanse</a:t>
+            </a:r>
+            <a:r>
+              <a:rPr lang="en-US" sz="3600" dirty="0"/>
+              <a:t> </a:t>
+            </a:r>
+            <a:r>
+              <a:rPr lang="en-US" sz="3600" dirty="0" err="1"/>
+              <a:t>interakcj</a:t>
+            </a:r>
+            <a:r>
+              <a:rPr lang="pl-PL" sz="3600" dirty="0"/>
+              <a:t>i.</a:t>
+            </a:r>
+          </a:p>
+          <a:p>
+            <a:pPr>
+              <a:buFont typeface="Wingdings" panose="05000000000000000000" pitchFamily="2" charset="2"/>
+              <a:buChar char="§"/>
+            </a:pPr>
+            <a:endParaRPr lang="en-US" sz="3600" dirty="0"/>
+          </a:p>
+        </p:txBody>
+      </p:sp>
       <p:pic>
         <p:nvPicPr>
-          <p:cNvPr id="3" name="Obraz 2">
-            <a:extLst>
-              <a:ext uri="{FF2B5EF4-FFF2-40B4-BE49-F238E27FC236}">
-                <a16:creationId xmlns:a16="http://schemas.microsoft.com/office/drawing/2014/main" id="{18B7D6B0-EEBD-D815-15AE-8724C4FB03A0}"/>
+          <p:cNvPr id="5" name="Obraz 4">
+            <a:extLst>
+              <a:ext uri="{FF2B5EF4-FFF2-40B4-BE49-F238E27FC236}">
+                <a16:creationId xmlns:a16="http://schemas.microsoft.com/office/drawing/2014/main" id="{B5D8E6B7-A676-19C9-FBC0-6F82629BCBDD}"/>
               </a:ext>
             </a:extLst>
           </p:cNvPr>
@@ -3599,54 +3751,18 @@
         </p:blipFill>
         <p:spPr>
           <a:xfrm>
-            <a:off x="633261" y="1465586"/>
-            <a:ext cx="10925477" cy="4552282"/>
+            <a:off x="8549941" y="3962400"/>
+            <a:ext cx="3261175" cy="2735179"/>
           </a:xfrm>
           <a:prstGeom prst="rect">
             <a:avLst/>
           </a:prstGeom>
         </p:spPr>
       </p:pic>
-      <p:sp>
-        <p:nvSpPr>
-          <p:cNvPr id="4" name="pole tekstowe 3">
-            <a:extLst>
-              <a:ext uri="{FF2B5EF4-FFF2-40B4-BE49-F238E27FC236}">
-                <a16:creationId xmlns:a16="http://schemas.microsoft.com/office/drawing/2014/main" id="{097C5563-DBC3-3CBF-3A70-8EC67806C1BA}"/>
-              </a:ext>
-            </a:extLst>
-          </p:cNvPr>
-          <p:cNvSpPr txBox="1"/>
-          <p:nvPr/>
-        </p:nvSpPr>
-        <p:spPr>
-          <a:xfrm>
-            <a:off x="4748463" y="545431"/>
-            <a:ext cx="4812632" cy="584775"/>
-          </a:xfrm>
-          <a:prstGeom prst="rect">
-            <a:avLst/>
-          </a:prstGeom>
-          <a:noFill/>
-        </p:spPr>
-        <p:txBody>
-          <a:bodyPr wrap="square" rtlCol="0">
-            <a:spAutoFit/>
-          </a:bodyPr>
-          <a:lstStyle/>
-          <a:p>
-            <a:r>
-              <a:rPr lang="pl-PL" sz="3200" dirty="0"/>
-              <a:t>Symulacja A</a:t>
-            </a:r>
-            <a:endParaRPr lang="en-US" sz="3200" dirty="0"/>
-          </a:p>
-        </p:txBody>
-      </p:sp>
     </p:spTree>
     <p:extLst>
       <p:ext uri="{BB962C8B-B14F-4D97-AF65-F5344CB8AC3E}">
-        <p14:creationId xmlns:p14="http://schemas.microsoft.com/office/powerpoint/2010/main" val="3206338473"/>
+        <p14:creationId xmlns:p14="http://schemas.microsoft.com/office/powerpoint/2010/main" val="1142525123"/>
       </p:ext>
     </p:extLst>
   </p:cSld>
@@ -3664,7 +3780,7 @@
         <p:cNvPr id="1" name="">
           <a:extLst>
             <a:ext uri="{FF2B5EF4-FFF2-40B4-BE49-F238E27FC236}">
-              <a16:creationId xmlns:a16="http://schemas.microsoft.com/office/drawing/2014/main" id="{371A5F96-3E07-ED20-3338-B070932A3402}"/>
+              <a16:creationId xmlns:a16="http://schemas.microsoft.com/office/drawing/2014/main" id="{94DBAB6D-D60C-623B-DF2D-F83D89DE38F1}"/>
             </a:ext>
           </a:extLst>
         </p:cNvPr>
@@ -3679,12 +3795,48 @@
           <a:chExt cx="0" cy="0"/>
         </a:xfrm>
       </p:grpSpPr>
-      <p:sp>
-        <p:nvSpPr>
-          <p:cNvPr id="4" name="pole tekstowe 3">
-            <a:extLst>
-              <a:ext uri="{FF2B5EF4-FFF2-40B4-BE49-F238E27FC236}">
-                <a16:creationId xmlns:a16="http://schemas.microsoft.com/office/drawing/2014/main" id="{7F79C7B7-EDAF-2875-B6A9-B59B7B014C1F}"/>
+      <p:pic>
+        <p:nvPicPr>
+          <p:cNvPr id="4" name="Obraz 3">
+            <a:extLst>
+              <a:ext uri="{FF2B5EF4-FFF2-40B4-BE49-F238E27FC236}">
+                <a16:creationId xmlns:a16="http://schemas.microsoft.com/office/drawing/2014/main" id="{B1180836-521C-4E00-E013-C85F79DFE369}"/>
+              </a:ext>
+            </a:extLst>
+          </p:cNvPr>
+          <p:cNvPicPr>
+            <a:picLocks noChangeAspect="1"/>
+          </p:cNvPicPr>
+          <p:nvPr/>
+        </p:nvPicPr>
+        <p:blipFill>
+          <a:blip r:embed="rId2">
+            <a:extLst>
+              <a:ext uri="{28A0092B-C50C-407E-A947-70E740481C1C}">
+                <a14:useLocalDpi xmlns:a14="http://schemas.microsoft.com/office/drawing/2010/main" val="0"/>
+              </a:ext>
+            </a:extLst>
+          </a:blip>
+          <a:stretch>
+            <a:fillRect/>
+          </a:stretch>
+        </p:blipFill>
+        <p:spPr>
+          <a:xfrm>
+            <a:off x="38110" y="144379"/>
+            <a:ext cx="12153890" cy="5064121"/>
+          </a:xfrm>
+          <a:prstGeom prst="rect">
+            <a:avLst/>
+          </a:prstGeom>
+        </p:spPr>
+      </p:pic>
+      <p:sp>
+        <p:nvSpPr>
+          <p:cNvPr id="6" name="pole tekstowe 5">
+            <a:extLst>
+              <a:ext uri="{FF2B5EF4-FFF2-40B4-BE49-F238E27FC236}">
+                <a16:creationId xmlns:a16="http://schemas.microsoft.com/office/drawing/2014/main" id="{F5E76416-235D-E25C-30AC-483D5D255A56}"/>
               </a:ext>
             </a:extLst>
           </p:cNvPr>
@@ -3693,8 +3845,8 @@
         </p:nvSpPr>
         <p:spPr>
           <a:xfrm>
-            <a:off x="4748463" y="545431"/>
-            <a:ext cx="4812632" cy="584775"/>
+            <a:off x="481262" y="5396392"/>
+            <a:ext cx="5213685" cy="969496"/>
           </a:xfrm>
           <a:prstGeom prst="rect">
             <a:avLst/>
@@ -3702,53 +3854,69 @@
           <a:noFill/>
         </p:spPr>
         <p:txBody>
+          <a:bodyPr wrap="square" rtlCol="0" anchor="b">
+            <a:spAutoFit/>
+          </a:bodyPr>
+          <a:lstStyle/>
+          <a:p>
+            <a:r>
+              <a:rPr lang="pl-PL" sz="1900" u="sng" dirty="0"/>
+              <a:t>Parametry</a:t>
+            </a:r>
+          </a:p>
+          <a:p>
+            <a:r>
+              <a:rPr lang="pl-PL" sz="1900" dirty="0"/>
+              <a:t>liczba cech: 6, liczba wariantów: 12</a:t>
+            </a:r>
+          </a:p>
+          <a:p>
+            <a:r>
+              <a:rPr lang="pl-PL" sz="1900" dirty="0"/>
+              <a:t>długość boku siatki: 30,  liczba iteracji: 2mln</a:t>
+            </a:r>
+          </a:p>
+        </p:txBody>
+      </p:sp>
+      <p:sp>
+        <p:nvSpPr>
+          <p:cNvPr id="8" name="pole tekstowe 7">
+            <a:extLst>
+              <a:ext uri="{FF2B5EF4-FFF2-40B4-BE49-F238E27FC236}">
+                <a16:creationId xmlns:a16="http://schemas.microsoft.com/office/drawing/2014/main" id="{9D5815F6-BA71-98FE-D1B4-B0D71CC12B44}"/>
+              </a:ext>
+            </a:extLst>
+          </p:cNvPr>
+          <p:cNvSpPr txBox="1"/>
+          <p:nvPr/>
+        </p:nvSpPr>
+        <p:spPr>
+          <a:xfrm>
+            <a:off x="8534400" y="5619530"/>
+            <a:ext cx="2316480" cy="523220"/>
+          </a:xfrm>
+          <a:prstGeom prst="rect">
+            <a:avLst/>
+          </a:prstGeom>
+          <a:noFill/>
+        </p:spPr>
+        <p:txBody>
           <a:bodyPr wrap="square" rtlCol="0">
             <a:spAutoFit/>
           </a:bodyPr>
           <a:lstStyle/>
           <a:p>
             <a:r>
-              <a:rPr lang="pl-PL" sz="3200" dirty="0"/>
-              <a:t>Symulacja B</a:t>
-            </a:r>
-            <a:endParaRPr lang="en-US" sz="3200" dirty="0"/>
-          </a:p>
-        </p:txBody>
-      </p:sp>
-      <p:pic>
-        <p:nvPicPr>
-          <p:cNvPr id="5" name="Obraz 4">
-            <a:extLst>
-              <a:ext uri="{FF2B5EF4-FFF2-40B4-BE49-F238E27FC236}">
-                <a16:creationId xmlns:a16="http://schemas.microsoft.com/office/drawing/2014/main" id="{BAE61DAC-EC9F-4311-0B8B-E18BB0CE6723}"/>
-              </a:ext>
-            </a:extLst>
-          </p:cNvPr>
-          <p:cNvPicPr>
-            <a:picLocks noChangeAspect="1"/>
-          </p:cNvPicPr>
-          <p:nvPr/>
-        </p:nvPicPr>
-        <p:blipFill>
-          <a:blip r:embed="rId2"/>
-          <a:stretch>
-            <a:fillRect/>
-          </a:stretch>
-        </p:blipFill>
-        <p:spPr>
-          <a:xfrm>
-            <a:off x="381000" y="1550069"/>
-            <a:ext cx="11430000" cy="4762500"/>
-          </a:xfrm>
-          <a:prstGeom prst="rect">
-            <a:avLst/>
-          </a:prstGeom>
-        </p:spPr>
-      </p:pic>
+              <a:rPr lang="pl-PL" sz="2800" b="1" dirty="0"/>
+              <a:t>Symulacja A</a:t>
+            </a:r>
+          </a:p>
+        </p:txBody>
+      </p:sp>
     </p:spTree>
     <p:extLst>
       <p:ext uri="{BB962C8B-B14F-4D97-AF65-F5344CB8AC3E}">
-        <p14:creationId xmlns:p14="http://schemas.microsoft.com/office/powerpoint/2010/main" val="3745341163"/>
+        <p14:creationId xmlns:p14="http://schemas.microsoft.com/office/powerpoint/2010/main" val="338881112"/>
       </p:ext>
     </p:extLst>
   </p:cSld>
@@ -3759,6 +3927,246 @@
 </file>
 
 <file path=ppt/slides/slide12.xml><?xml version="1.0" encoding="utf-8"?>
+<p:sld xmlns:a="http://schemas.openxmlformats.org/drawingml/2006/main" xmlns:r="http://schemas.openxmlformats.org/officeDocument/2006/relationships" xmlns:p="http://schemas.openxmlformats.org/presentationml/2006/main">
+  <p:cSld>
+    <p:spTree>
+      <p:nvGrpSpPr>
+        <p:cNvPr id="1" name=""/>
+        <p:cNvGrpSpPr/>
+        <p:nvPr/>
+      </p:nvGrpSpPr>
+      <p:grpSpPr>
+        <a:xfrm>
+          <a:off x="0" y="0"/>
+          <a:ext cx="0" cy="0"/>
+          <a:chOff x="0" y="0"/>
+          <a:chExt cx="0" cy="0"/>
+        </a:xfrm>
+      </p:grpSpPr>
+      <p:pic>
+        <p:nvPicPr>
+          <p:cNvPr id="5" name="Obraz 4">
+            <a:extLst>
+              <a:ext uri="{FF2B5EF4-FFF2-40B4-BE49-F238E27FC236}">
+                <a16:creationId xmlns:a16="http://schemas.microsoft.com/office/drawing/2014/main" id="{97A5FA6D-A409-3767-1C9F-4EEC8B12B3FD}"/>
+              </a:ext>
+            </a:extLst>
+          </p:cNvPr>
+          <p:cNvPicPr>
+            <a:picLocks noChangeAspect="1"/>
+          </p:cNvPicPr>
+          <p:nvPr/>
+        </p:nvPicPr>
+        <p:blipFill>
+          <a:blip r:embed="rId2">
+            <a:extLst>
+              <a:ext uri="{28A0092B-C50C-407E-A947-70E740481C1C}">
+                <a14:useLocalDpi xmlns:a14="http://schemas.microsoft.com/office/drawing/2010/main" val="0"/>
+              </a:ext>
+            </a:extLst>
+          </a:blip>
+          <a:stretch>
+            <a:fillRect/>
+          </a:stretch>
+        </p:blipFill>
+        <p:spPr>
+          <a:xfrm>
+            <a:off x="25667" y="144379"/>
+            <a:ext cx="12166333" cy="5069305"/>
+          </a:xfrm>
+          <a:prstGeom prst="rect">
+            <a:avLst/>
+          </a:prstGeom>
+        </p:spPr>
+      </p:pic>
+      <p:sp>
+        <p:nvSpPr>
+          <p:cNvPr id="3" name="pole tekstowe 2">
+            <a:extLst>
+              <a:ext uri="{FF2B5EF4-FFF2-40B4-BE49-F238E27FC236}">
+                <a16:creationId xmlns:a16="http://schemas.microsoft.com/office/drawing/2014/main" id="{75CDD93B-F121-21E0-1374-5C6EF0B1751B}"/>
+              </a:ext>
+            </a:extLst>
+          </p:cNvPr>
+          <p:cNvSpPr txBox="1"/>
+          <p:nvPr/>
+        </p:nvSpPr>
+        <p:spPr>
+          <a:xfrm>
+            <a:off x="481262" y="5396392"/>
+            <a:ext cx="5213685" cy="969496"/>
+          </a:xfrm>
+          <a:prstGeom prst="rect">
+            <a:avLst/>
+          </a:prstGeom>
+          <a:noFill/>
+        </p:spPr>
+        <p:txBody>
+          <a:bodyPr wrap="square" rtlCol="0" anchor="b">
+            <a:spAutoFit/>
+          </a:bodyPr>
+          <a:lstStyle/>
+          <a:p>
+            <a:r>
+              <a:rPr lang="pl-PL" sz="1900" u="sng" dirty="0"/>
+              <a:t>Parametry</a:t>
+            </a:r>
+          </a:p>
+          <a:p>
+            <a:r>
+              <a:rPr lang="pl-PL" sz="1900" dirty="0"/>
+              <a:t>liczba cech: 6, liczba wariantów: 12</a:t>
+            </a:r>
+          </a:p>
+          <a:p>
+            <a:r>
+              <a:rPr lang="pl-PL" sz="1900" dirty="0"/>
+              <a:t>długość boku siatki: 30,  liczba iteracji: 1mln</a:t>
+            </a:r>
+          </a:p>
+        </p:txBody>
+      </p:sp>
+      <p:sp>
+        <p:nvSpPr>
+          <p:cNvPr id="6" name="pole tekstowe 5">
+            <a:extLst>
+              <a:ext uri="{FF2B5EF4-FFF2-40B4-BE49-F238E27FC236}">
+                <a16:creationId xmlns:a16="http://schemas.microsoft.com/office/drawing/2014/main" id="{230A3FC0-811A-7882-6409-E81F1253BC56}"/>
+              </a:ext>
+            </a:extLst>
+          </p:cNvPr>
+          <p:cNvSpPr txBox="1"/>
+          <p:nvPr/>
+        </p:nvSpPr>
+        <p:spPr>
+          <a:xfrm>
+            <a:off x="8534400" y="5619530"/>
+            <a:ext cx="2316480" cy="523220"/>
+          </a:xfrm>
+          <a:prstGeom prst="rect">
+            <a:avLst/>
+          </a:prstGeom>
+          <a:noFill/>
+        </p:spPr>
+        <p:txBody>
+          <a:bodyPr wrap="square" rtlCol="0">
+            <a:spAutoFit/>
+          </a:bodyPr>
+          <a:lstStyle/>
+          <a:p>
+            <a:r>
+              <a:rPr lang="pl-PL" sz="2800" b="1" dirty="0"/>
+              <a:t>Symulacja B</a:t>
+            </a:r>
+          </a:p>
+        </p:txBody>
+      </p:sp>
+    </p:spTree>
+    <p:extLst>
+      <p:ext uri="{BB962C8B-B14F-4D97-AF65-F5344CB8AC3E}">
+        <p14:creationId xmlns:p14="http://schemas.microsoft.com/office/powerpoint/2010/main" val="438986128"/>
+      </p:ext>
+    </p:extLst>
+  </p:cSld>
+  <p:clrMapOvr>
+    <a:masterClrMapping/>
+  </p:clrMapOvr>
+</p:sld>
+</file>
+
+<file path=ppt/slides/slide13.xml><?xml version="1.0" encoding="utf-8"?>
+<p:sld xmlns:a="http://schemas.openxmlformats.org/drawingml/2006/main" xmlns:r="http://schemas.openxmlformats.org/officeDocument/2006/relationships" xmlns:p="http://schemas.openxmlformats.org/presentationml/2006/main">
+  <p:cSld>
+    <p:spTree>
+      <p:nvGrpSpPr>
+        <p:cNvPr id="1" name=""/>
+        <p:cNvGrpSpPr/>
+        <p:nvPr/>
+      </p:nvGrpSpPr>
+      <p:grpSpPr>
+        <a:xfrm>
+          <a:off x="0" y="0"/>
+          <a:ext cx="0" cy="0"/>
+          <a:chOff x="0" y="0"/>
+          <a:chExt cx="0" cy="0"/>
+        </a:xfrm>
+      </p:grpSpPr>
+      <p:sp>
+        <p:nvSpPr>
+          <p:cNvPr id="2" name="Tytuł 1">
+            <a:extLst>
+              <a:ext uri="{FF2B5EF4-FFF2-40B4-BE49-F238E27FC236}">
+                <a16:creationId xmlns:a16="http://schemas.microsoft.com/office/drawing/2014/main" id="{958507E3-A492-ADE9-9CC9-39CA0FE7FF78}"/>
+              </a:ext>
+            </a:extLst>
+          </p:cNvPr>
+          <p:cNvSpPr>
+            <a:spLocks noGrp="1"/>
+          </p:cNvSpPr>
+          <p:nvPr>
+            <p:ph type="title"/>
+          </p:nvPr>
+        </p:nvSpPr>
+        <p:spPr/>
+        <p:txBody>
+          <a:bodyPr/>
+          <a:lstStyle/>
+          <a:p>
+            <a:r>
+              <a:rPr lang="pl-PL" dirty="0"/>
+              <a:t>Rezultat rozszerzenia modelu</a:t>
+            </a:r>
+            <a:endParaRPr lang="en-US" dirty="0"/>
+          </a:p>
+        </p:txBody>
+      </p:sp>
+      <p:sp>
+        <p:nvSpPr>
+          <p:cNvPr id="3" name="Symbol zastępczy zawartości 2">
+            <a:extLst>
+              <a:ext uri="{FF2B5EF4-FFF2-40B4-BE49-F238E27FC236}">
+                <a16:creationId xmlns:a16="http://schemas.microsoft.com/office/drawing/2014/main" id="{0A2EC9DE-B8DC-3284-A196-82B0FE9D5307}"/>
+              </a:ext>
+            </a:extLst>
+          </p:cNvPr>
+          <p:cNvSpPr>
+            <a:spLocks noGrp="1"/>
+          </p:cNvSpPr>
+          <p:nvPr>
+            <p:ph idx="1"/>
+          </p:nvPr>
+        </p:nvSpPr>
+        <p:spPr/>
+        <p:txBody>
+          <a:bodyPr/>
+          <a:lstStyle/>
+          <a:p>
+            <a:pPr>
+              <a:buFont typeface="Wingdings" panose="05000000000000000000" pitchFamily="2" charset="2"/>
+              <a:buChar char="§"/>
+            </a:pPr>
+            <a:r>
+              <a:rPr lang="pl-PL" dirty="0"/>
+              <a:t>Szybsze ujednolicenie poprzez posiadanie większej liczby sąsiadów.</a:t>
+            </a:r>
+            <a:endParaRPr lang="en-US" dirty="0"/>
+          </a:p>
+        </p:txBody>
+      </p:sp>
+    </p:spTree>
+    <p:extLst>
+      <p:ext uri="{BB962C8B-B14F-4D97-AF65-F5344CB8AC3E}">
+        <p14:creationId xmlns:p14="http://schemas.microsoft.com/office/powerpoint/2010/main" val="907463827"/>
+      </p:ext>
+    </p:extLst>
+  </p:cSld>
+  <p:clrMapOvr>
+    <a:masterClrMapping/>
+  </p:clrMapOvr>
+</p:sld>
+</file>
+
+<file path=ppt/slides/slide14.xml><?xml version="1.0" encoding="utf-8"?>
 <p:sld xmlns:a="http://schemas.openxmlformats.org/drawingml/2006/main" xmlns:r="http://schemas.openxmlformats.org/officeDocument/2006/relationships" xmlns:p="http://schemas.openxmlformats.org/presentationml/2006/main">
   <p:cSld>
     <p:spTree>
@@ -4768,23 +5176,11 @@
             </a:r>
             <a:r>
               <a:rPr lang="en-US" dirty="0"/>
-              <a:t>: Program </a:t>
-            </a:r>
-            <a:r>
-              <a:rPr lang="en-US" dirty="0" err="1"/>
-              <a:t>wybiera</a:t>
-            </a:r>
-            <a:r>
-              <a:rPr lang="en-US" dirty="0"/>
-              <a:t> </a:t>
-            </a:r>
-            <a:r>
-              <a:rPr lang="en-US" dirty="0" err="1"/>
-              <a:t>losowo</a:t>
-            </a:r>
-            <a:r>
-              <a:rPr lang="en-US" dirty="0"/>
-              <a:t> </a:t>
+              <a:t>: </a:t>
+            </a:r>
+            <a:r>
+              <a:rPr lang="pl-PL" dirty="0"/>
+              <a:t>losowo wybieramy </a:t>
             </a:r>
             <a:r>
               <a:rPr lang="en-US" dirty="0" err="1"/>
@@ -6036,7 +6432,13 @@
   <p:cSld>
     <p:spTree>
       <p:nvGrpSpPr>
-        <p:cNvPr id="1" name=""/>
+        <p:cNvPr id="1" name="">
+          <a:extLst>
+            <a:ext uri="{FF2B5EF4-FFF2-40B4-BE49-F238E27FC236}">
+              <a16:creationId xmlns:a16="http://schemas.microsoft.com/office/drawing/2014/main" id="{C975BD9F-7388-27B7-6E97-13AEFA7F3079}"/>
+            </a:ext>
+          </a:extLst>
+        </p:cNvPr>
         <p:cNvGrpSpPr/>
         <p:nvPr/>
       </p:nvGrpSpPr>
@@ -6048,94 +6450,99 @@
           <a:chExt cx="0" cy="0"/>
         </a:xfrm>
       </p:grpSpPr>
-      <p:sp>
-        <p:nvSpPr>
-          <p:cNvPr id="2" name="Tytuł 1">
-            <a:extLst>
-              <a:ext uri="{FF2B5EF4-FFF2-40B4-BE49-F238E27FC236}">
-                <a16:creationId xmlns:a16="http://schemas.microsoft.com/office/drawing/2014/main" id="{D0B8A69A-FCE4-1153-712A-FAC99C76CCDF}"/>
-              </a:ext>
-            </a:extLst>
-          </p:cNvPr>
-          <p:cNvSpPr>
-            <a:spLocks noGrp="1"/>
-          </p:cNvSpPr>
-          <p:nvPr>
-            <p:ph type="ctrTitle"/>
-          </p:nvPr>
-        </p:nvSpPr>
-        <p:spPr/>
-        <p:txBody>
-          <a:bodyPr/>
-          <a:lstStyle/>
-          <a:p>
-            <a:r>
-              <a:rPr lang="pl-PL" dirty="0"/>
-              <a:t>	TU CALE ZDJECIA I STATYSTYKA </a:t>
-            </a:r>
-            <a:endParaRPr lang="en-US" dirty="0"/>
-          </a:p>
-        </p:txBody>
-      </p:sp>
-      <p:sp>
-        <p:nvSpPr>
-          <p:cNvPr id="3" name="Podtytuł 2">
-            <a:extLst>
-              <a:ext uri="{FF2B5EF4-FFF2-40B4-BE49-F238E27FC236}">
-                <a16:creationId xmlns:a16="http://schemas.microsoft.com/office/drawing/2014/main" id="{53B25650-7C85-A4E5-2F5F-CB2D99D6E4C4}"/>
-              </a:ext>
-            </a:extLst>
-          </p:cNvPr>
-          <p:cNvSpPr>
-            <a:spLocks noGrp="1"/>
-          </p:cNvSpPr>
-          <p:nvPr>
-            <p:ph type="subTitle" idx="1"/>
-          </p:nvPr>
-        </p:nvSpPr>
-        <p:spPr/>
-        <p:txBody>
-          <a:bodyPr>
-            <a:normAutofit fontScale="92500"/>
+      <p:pic>
+        <p:nvPicPr>
+          <p:cNvPr id="4" name="Obraz 3">
+            <a:extLst>
+              <a:ext uri="{FF2B5EF4-FFF2-40B4-BE49-F238E27FC236}">
+                <a16:creationId xmlns:a16="http://schemas.microsoft.com/office/drawing/2014/main" id="{4693E866-FE5B-AD44-8FA5-3862CBAF09FA}"/>
+              </a:ext>
+            </a:extLst>
+          </p:cNvPr>
+          <p:cNvPicPr>
+            <a:picLocks noChangeAspect="1"/>
+          </p:cNvPicPr>
+          <p:nvPr/>
+        </p:nvPicPr>
+        <p:blipFill>
+          <a:blip r:embed="rId2">
+            <a:extLst>
+              <a:ext uri="{28A0092B-C50C-407E-A947-70E740481C1C}">
+                <a14:useLocalDpi xmlns:a14="http://schemas.microsoft.com/office/drawing/2010/main" val="0"/>
+              </a:ext>
+            </a:extLst>
+          </a:blip>
+          <a:stretch>
+            <a:fillRect/>
+          </a:stretch>
+        </p:blipFill>
+        <p:spPr>
+          <a:xfrm>
+            <a:off x="2744536" y="76200"/>
+            <a:ext cx="8940800" cy="6705600"/>
+          </a:xfrm>
+          <a:prstGeom prst="rect">
+            <a:avLst/>
+          </a:prstGeom>
+        </p:spPr>
+      </p:pic>
+      <p:sp>
+        <p:nvSpPr>
+          <p:cNvPr id="3" name="pole tekstowe 2">
+            <a:extLst>
+              <a:ext uri="{FF2B5EF4-FFF2-40B4-BE49-F238E27FC236}">
+                <a16:creationId xmlns:a16="http://schemas.microsoft.com/office/drawing/2014/main" id="{3B774FEC-EBFA-B662-1372-7D093BD8B71A}"/>
+              </a:ext>
+            </a:extLst>
+          </p:cNvPr>
+          <p:cNvSpPr txBox="1"/>
+          <p:nvPr/>
+        </p:nvSpPr>
+        <p:spPr>
+          <a:xfrm>
+            <a:off x="481262" y="5104004"/>
+            <a:ext cx="3100138" cy="1261884"/>
+          </a:xfrm>
+          <a:prstGeom prst="rect">
+            <a:avLst/>
+          </a:prstGeom>
+          <a:noFill/>
+        </p:spPr>
+        <p:txBody>
+          <a:bodyPr wrap="square" rtlCol="0" anchor="b">
+            <a:spAutoFit/>
           </a:bodyPr>
           <a:lstStyle/>
           <a:p>
             <a:r>
-              <a:rPr lang="pl-PL" sz="7200" dirty="0">
-                <a:highlight>
-                  <a:srgbClr val="FFFF00"/>
-                </a:highlight>
-              </a:rPr>
-              <a:t>DO ZROBIENIA </a:t>
-            </a:r>
-            <a:r>
-              <a:rPr lang="pl-PL" sz="7200" dirty="0" err="1">
-                <a:highlight>
-                  <a:srgbClr val="FFFF00"/>
-                </a:highlight>
-              </a:rPr>
-              <a:t>sZyMoN</a:t>
-            </a:r>
-            <a:r>
-              <a:rPr lang="pl-PL" sz="7200" dirty="0">
-                <a:highlight>
-                  <a:srgbClr val="FFFF00"/>
-                </a:highlight>
-              </a:rPr>
-              <a:t>!</a:t>
-            </a:r>
-            <a:endParaRPr lang="en-US" sz="7200" dirty="0">
-              <a:highlight>
-                <a:srgbClr val="FFFF00"/>
-              </a:highlight>
-            </a:endParaRPr>
+              <a:rPr lang="pl-PL" sz="1900" u="sng" dirty="0"/>
+              <a:t>Parametry</a:t>
+            </a:r>
+          </a:p>
+          <a:p>
+            <a:r>
+              <a:rPr lang="pl-PL" sz="1900" dirty="0"/>
+              <a:t>liczba cech: 5</a:t>
+            </a:r>
+          </a:p>
+          <a:p>
+            <a:r>
+              <a:rPr lang="pl-PL" sz="1900" dirty="0"/>
+              <a:t>długość boku siatki: 10</a:t>
+            </a:r>
+          </a:p>
+          <a:p>
+            <a:r>
+              <a:rPr lang="pl-PL" sz="1900" dirty="0"/>
+              <a:t>liczba iteracji: &lt;300000</a:t>
+            </a:r>
           </a:p>
         </p:txBody>
       </p:sp>
     </p:spTree>
     <p:extLst>
       <p:ext uri="{BB962C8B-B14F-4D97-AF65-F5344CB8AC3E}">
-        <p14:creationId xmlns:p14="http://schemas.microsoft.com/office/powerpoint/2010/main" val="3546194582"/>
+        <p14:creationId xmlns:p14="http://schemas.microsoft.com/office/powerpoint/2010/main" val="2455441191"/>
       </p:ext>
     </p:extLst>
   </p:cSld>
@@ -6150,7 +6557,13 @@
   <p:cSld>
     <p:spTree>
       <p:nvGrpSpPr>
-        <p:cNvPr id="1" name=""/>
+        <p:cNvPr id="1" name="">
+          <a:extLst>
+            <a:ext uri="{FF2B5EF4-FFF2-40B4-BE49-F238E27FC236}">
+              <a16:creationId xmlns:a16="http://schemas.microsoft.com/office/drawing/2014/main" id="{3AEBEEFD-4777-E5BE-A441-F2ED6C94E4B5}"/>
+            </a:ext>
+          </a:extLst>
+        </p:cNvPr>
         <p:cNvGrpSpPr/>
         <p:nvPr/>
       </p:nvGrpSpPr>
@@ -6162,60 +6575,164 @@
           <a:chExt cx="0" cy="0"/>
         </a:xfrm>
       </p:grpSpPr>
-      <p:sp>
-        <p:nvSpPr>
-          <p:cNvPr id="2" name="Tytuł 1">
-            <a:extLst>
-              <a:ext uri="{FF2B5EF4-FFF2-40B4-BE49-F238E27FC236}">
-                <a16:creationId xmlns:a16="http://schemas.microsoft.com/office/drawing/2014/main" id="{E8BE52D9-B0DB-27E5-E0DD-1371A853577A}"/>
-              </a:ext>
-            </a:extLst>
-          </p:cNvPr>
-          <p:cNvSpPr>
-            <a:spLocks noGrp="1"/>
-          </p:cNvSpPr>
-          <p:nvPr>
-            <p:ph type="title"/>
-          </p:nvPr>
-        </p:nvSpPr>
-        <p:spPr/>
-        <p:txBody>
-          <a:bodyPr/>
+      <p:pic>
+        <p:nvPicPr>
+          <p:cNvPr id="4" name="Obraz 3">
+            <a:extLst>
+              <a:ext uri="{FF2B5EF4-FFF2-40B4-BE49-F238E27FC236}">
+                <a16:creationId xmlns:a16="http://schemas.microsoft.com/office/drawing/2014/main" id="{8AA74A69-C74E-CA5A-4969-7D4FF901DFA8}"/>
+              </a:ext>
+            </a:extLst>
+          </p:cNvPr>
+          <p:cNvPicPr>
+            <a:picLocks noChangeAspect="1"/>
+          </p:cNvPicPr>
+          <p:nvPr/>
+        </p:nvPicPr>
+        <p:blipFill>
+          <a:blip r:embed="rId2">
+            <a:extLst>
+              <a:ext uri="{28A0092B-C50C-407E-A947-70E740481C1C}">
+                <a14:useLocalDpi xmlns:a14="http://schemas.microsoft.com/office/drawing/2010/main" val="0"/>
+              </a:ext>
+            </a:extLst>
+          </a:blip>
+          <a:stretch>
+            <a:fillRect/>
+          </a:stretch>
+        </p:blipFill>
+        <p:spPr>
+          <a:xfrm>
+            <a:off x="2785790" y="144378"/>
+            <a:ext cx="8758990" cy="6569243"/>
+          </a:xfrm>
+          <a:prstGeom prst="rect">
+            <a:avLst/>
+          </a:prstGeom>
+        </p:spPr>
+      </p:pic>
+      <p:sp>
+        <p:nvSpPr>
+          <p:cNvPr id="3" name="pole tekstowe 2">
+            <a:extLst>
+              <a:ext uri="{FF2B5EF4-FFF2-40B4-BE49-F238E27FC236}">
+                <a16:creationId xmlns:a16="http://schemas.microsoft.com/office/drawing/2014/main" id="{335EFD6F-418E-DEBF-4D57-0A479983EECB}"/>
+              </a:ext>
+            </a:extLst>
+          </p:cNvPr>
+          <p:cNvSpPr txBox="1"/>
+          <p:nvPr/>
+        </p:nvSpPr>
+        <p:spPr>
+          <a:xfrm>
+            <a:off x="481262" y="5104004"/>
+            <a:ext cx="3100138" cy="1261884"/>
+          </a:xfrm>
+          <a:prstGeom prst="rect">
+            <a:avLst/>
+          </a:prstGeom>
+          <a:noFill/>
+        </p:spPr>
+        <p:txBody>
+          <a:bodyPr wrap="square" rtlCol="0" anchor="b">
+            <a:spAutoFit/>
+          </a:bodyPr>
           <a:lstStyle/>
           <a:p>
-            <a:endParaRPr lang="pl-PL"/>
-          </a:p>
-        </p:txBody>
-      </p:sp>
-      <p:sp>
-        <p:nvSpPr>
-          <p:cNvPr id="3" name="Symbol zastępczy zawartości 2">
-            <a:extLst>
-              <a:ext uri="{FF2B5EF4-FFF2-40B4-BE49-F238E27FC236}">
-                <a16:creationId xmlns:a16="http://schemas.microsoft.com/office/drawing/2014/main" id="{5129E3C5-E2F4-479C-1370-A47643ED6B4C}"/>
-              </a:ext>
-            </a:extLst>
-          </p:cNvPr>
-          <p:cNvSpPr>
-            <a:spLocks noGrp="1"/>
-          </p:cNvSpPr>
-          <p:nvPr>
-            <p:ph idx="1"/>
-          </p:nvPr>
-        </p:nvSpPr>
-        <p:spPr/>
-        <p:txBody>
-          <a:bodyPr/>
+            <a:r>
+              <a:rPr lang="pl-PL" sz="1900" u="sng" dirty="0"/>
+              <a:t>Parametry</a:t>
+            </a:r>
+          </a:p>
+          <a:p>
+            <a:r>
+              <a:rPr lang="pl-PL" sz="1900" dirty="0"/>
+              <a:t>liczba cech: 5</a:t>
+            </a:r>
+          </a:p>
+          <a:p>
+            <a:r>
+              <a:rPr lang="pl-PL" sz="1900" dirty="0"/>
+              <a:t>długość boku siatki: 10</a:t>
+            </a:r>
+          </a:p>
+          <a:p>
+            <a:r>
+              <a:rPr lang="pl-PL" sz="1900" dirty="0"/>
+              <a:t>liczba iteracji: &lt;400000</a:t>
+            </a:r>
+          </a:p>
+        </p:txBody>
+      </p:sp>
+      <p:pic>
+        <p:nvPicPr>
+          <p:cNvPr id="6" name="Obraz 5">
+            <a:extLst>
+              <a:ext uri="{FF2B5EF4-FFF2-40B4-BE49-F238E27FC236}">
+                <a16:creationId xmlns:a16="http://schemas.microsoft.com/office/drawing/2014/main" id="{BD0C09B4-26CE-4575-BDA9-DE177BA3BAD9}"/>
+              </a:ext>
+            </a:extLst>
+          </p:cNvPr>
+          <p:cNvPicPr>
+            <a:picLocks noChangeAspect="1"/>
+          </p:cNvPicPr>
+          <p:nvPr/>
+        </p:nvPicPr>
+        <p:blipFill>
+          <a:blip r:embed="rId3"/>
+          <a:stretch>
+            <a:fillRect/>
+          </a:stretch>
+        </p:blipFill>
+        <p:spPr>
+          <a:xfrm>
+            <a:off x="5651792" y="304800"/>
+            <a:ext cx="3877218" cy="288364"/>
+          </a:xfrm>
+          <a:prstGeom prst="rect">
+            <a:avLst/>
+          </a:prstGeom>
+        </p:spPr>
+      </p:pic>
+      <p:sp>
+        <p:nvSpPr>
+          <p:cNvPr id="7" name="pole tekstowe 6">
+            <a:extLst>
+              <a:ext uri="{FF2B5EF4-FFF2-40B4-BE49-F238E27FC236}">
+                <a16:creationId xmlns:a16="http://schemas.microsoft.com/office/drawing/2014/main" id="{55926E9D-9C6D-461D-CA0A-C9934EBC198E}"/>
+              </a:ext>
+            </a:extLst>
+          </p:cNvPr>
+          <p:cNvSpPr txBox="1"/>
+          <p:nvPr/>
+        </p:nvSpPr>
+        <p:spPr>
+          <a:xfrm>
+            <a:off x="3446284" y="288758"/>
+            <a:ext cx="8288233" cy="384721"/>
+          </a:xfrm>
+          <a:prstGeom prst="rect">
+            <a:avLst/>
+          </a:prstGeom>
+          <a:noFill/>
+        </p:spPr>
+        <p:txBody>
+          <a:bodyPr wrap="square" rtlCol="0">
+            <a:spAutoFit/>
+          </a:bodyPr>
           <a:lstStyle/>
           <a:p>
-            <a:endParaRPr lang="pl-PL"/>
+            <a:r>
+              <a:rPr lang="pl-PL" sz="1900" dirty="0"/>
+              <a:t>Unormowana wielkość największego regionu w zależności od liczby wariantów</a:t>
+            </a:r>
           </a:p>
         </p:txBody>
       </p:sp>
     </p:spTree>
     <p:extLst>
       <p:ext uri="{BB962C8B-B14F-4D97-AF65-F5344CB8AC3E}">
-        <p14:creationId xmlns:p14="http://schemas.microsoft.com/office/powerpoint/2010/main" val="249834709"/>
+        <p14:creationId xmlns:p14="http://schemas.microsoft.com/office/powerpoint/2010/main" val="1244680839"/>
       </p:ext>
     </p:extLst>
   </p:cSld>
@@ -6230,7 +6747,13 @@
   <p:cSld>
     <p:spTree>
       <p:nvGrpSpPr>
-        <p:cNvPr id="1" name=""/>
+        <p:cNvPr id="1" name="">
+          <a:extLst>
+            <a:ext uri="{FF2B5EF4-FFF2-40B4-BE49-F238E27FC236}">
+              <a16:creationId xmlns:a16="http://schemas.microsoft.com/office/drawing/2014/main" id="{0346A47C-9D1B-ADDB-C999-E46054B35C68}"/>
+            </a:ext>
+          </a:extLst>
+        </p:cNvPr>
         <p:cNvGrpSpPr/>
         <p:nvPr/>
       </p:nvGrpSpPr>
@@ -6242,209 +6765,12 @@
           <a:chExt cx="0" cy="0"/>
         </a:xfrm>
       </p:grpSpPr>
-      <p:sp>
-        <p:nvSpPr>
-          <p:cNvPr id="2" name="Tytuł 1">
-            <a:extLst>
-              <a:ext uri="{FF2B5EF4-FFF2-40B4-BE49-F238E27FC236}">
-                <a16:creationId xmlns:a16="http://schemas.microsoft.com/office/drawing/2014/main" id="{77407CC0-3BB3-4563-A997-6BDBBB130FFE}"/>
-              </a:ext>
-            </a:extLst>
-          </p:cNvPr>
-          <p:cNvSpPr>
-            <a:spLocks noGrp="1"/>
-          </p:cNvSpPr>
-          <p:nvPr>
-            <p:ph type="title"/>
-          </p:nvPr>
-        </p:nvSpPr>
-        <p:spPr/>
-        <p:txBody>
-          <a:bodyPr/>
-          <a:lstStyle/>
-          <a:p>
-            <a:r>
-              <a:rPr lang="pl-PL" dirty="0"/>
-              <a:t>Rozszerzenie modelu</a:t>
-            </a:r>
-            <a:endParaRPr lang="en-US" dirty="0"/>
-          </a:p>
-        </p:txBody>
-      </p:sp>
-      <p:sp>
-        <p:nvSpPr>
-          <p:cNvPr id="3" name="Symbol zastępczy zawartości 2">
-            <a:extLst>
-              <a:ext uri="{FF2B5EF4-FFF2-40B4-BE49-F238E27FC236}">
-                <a16:creationId xmlns:a16="http://schemas.microsoft.com/office/drawing/2014/main" id="{BA4F3297-7DD6-0EF4-82F1-773AB2F43F61}"/>
-              </a:ext>
-            </a:extLst>
-          </p:cNvPr>
-          <p:cNvSpPr>
-            <a:spLocks noGrp="1"/>
-          </p:cNvSpPr>
-          <p:nvPr>
-            <p:ph idx="1"/>
-          </p:nvPr>
-        </p:nvSpPr>
-        <p:spPr>
-          <a:xfrm>
-            <a:off x="838200" y="1825625"/>
-            <a:ext cx="10198768" cy="4351338"/>
-          </a:xfrm>
-        </p:spPr>
-        <p:txBody>
-          <a:bodyPr>
-            <a:normAutofit/>
-          </a:bodyPr>
-          <a:lstStyle/>
-          <a:p>
-            <a:pPr>
-              <a:buFont typeface="Wingdings" panose="05000000000000000000" pitchFamily="2" charset="2"/>
-              <a:buChar char="§"/>
-            </a:pPr>
-            <a:r>
-              <a:rPr lang="pl-PL" sz="3600" dirty="0"/>
-              <a:t>Extended – zwiększamy sąsiedztwo o przekątne (do 8 z 4).</a:t>
-            </a:r>
-          </a:p>
-          <a:p>
-            <a:pPr>
-              <a:buFont typeface="Wingdings" panose="05000000000000000000" pitchFamily="2" charset="2"/>
-              <a:buChar char="§"/>
-            </a:pPr>
-            <a:r>
-              <a:rPr lang="pl-PL" sz="3600" dirty="0"/>
-              <a:t>Model toroidalny - </a:t>
-            </a:r>
-            <a:r>
-              <a:rPr lang="en-US" sz="3600" dirty="0" err="1"/>
-              <a:t>Zwijamy</a:t>
-            </a:r>
-            <a:r>
-              <a:rPr lang="en-US" sz="3600" dirty="0"/>
-              <a:t> </a:t>
-            </a:r>
-            <a:r>
-              <a:rPr lang="en-US" sz="3600" dirty="0" err="1"/>
-              <a:t>siatkę</a:t>
-            </a:r>
-            <a:r>
-              <a:rPr lang="en-US" sz="3600" dirty="0"/>
-              <a:t> w </a:t>
-            </a:r>
-            <a:r>
-              <a:rPr lang="en-US" sz="3600" dirty="0" err="1"/>
-              <a:t>kształt</a:t>
-            </a:r>
-            <a:r>
-              <a:rPr lang="en-US" sz="3600" dirty="0"/>
-              <a:t> </a:t>
-            </a:r>
-            <a:r>
-              <a:rPr lang="en-US" sz="3600" dirty="0" err="1"/>
-              <a:t>torusa</a:t>
-            </a:r>
-            <a:r>
-              <a:rPr lang="en-US" sz="3600" dirty="0"/>
-              <a:t> – </a:t>
-            </a:r>
-            <a:r>
-              <a:rPr lang="en-US" sz="3600" dirty="0" err="1"/>
-              <a:t>agenci</a:t>
-            </a:r>
-            <a:r>
-              <a:rPr lang="en-US" sz="3600" dirty="0"/>
-              <a:t> z </a:t>
-            </a:r>
-            <a:r>
-              <a:rPr lang="en-US" sz="3600" dirty="0" err="1"/>
-              <a:t>lewej</a:t>
-            </a:r>
-            <a:r>
-              <a:rPr lang="en-US" sz="3600" dirty="0"/>
-              <a:t> </a:t>
-            </a:r>
-            <a:r>
-              <a:rPr lang="en-US" sz="3600" dirty="0" err="1"/>
-              <a:t>krawędzi</a:t>
-            </a:r>
-            <a:r>
-              <a:rPr lang="en-US" sz="3600" dirty="0"/>
-              <a:t> </a:t>
-            </a:r>
-            <a:r>
-              <a:rPr lang="en-US" sz="3600" dirty="0" err="1"/>
-              <a:t>łączą</a:t>
-            </a:r>
-            <a:r>
-              <a:rPr lang="en-US" sz="3600" dirty="0"/>
-              <a:t> </a:t>
-            </a:r>
-            <a:r>
-              <a:rPr lang="en-US" sz="3600" dirty="0" err="1"/>
-              <a:t>się</a:t>
-            </a:r>
-            <a:r>
-              <a:rPr lang="en-US" sz="3600" dirty="0"/>
-              <a:t> </a:t>
-            </a:r>
-            <a:r>
-              <a:rPr lang="en-US" sz="3600" dirty="0" err="1"/>
-              <a:t>bezpośrednio</a:t>
-            </a:r>
-            <a:r>
-              <a:rPr lang="en-US" sz="3600" dirty="0"/>
-              <a:t> z </a:t>
-            </a:r>
-            <a:r>
-              <a:rPr lang="en-US" sz="3600" dirty="0" err="1"/>
-              <a:t>prawą</a:t>
-            </a:r>
-            <a:r>
-              <a:rPr lang="en-US" sz="3600" dirty="0"/>
-              <a:t>, </a:t>
-            </a:r>
-            <a:r>
-              <a:rPr lang="en-US" sz="3600" dirty="0" err="1"/>
-              <a:t>wyrównując</a:t>
-            </a:r>
-            <a:r>
-              <a:rPr lang="en-US" sz="3600" dirty="0"/>
-              <a:t> </a:t>
-            </a:r>
-            <a:r>
-              <a:rPr lang="en-US" sz="3600" dirty="0" err="1"/>
-              <a:t>szanse</a:t>
-            </a:r>
-            <a:r>
-              <a:rPr lang="en-US" sz="3600" dirty="0"/>
-              <a:t> </a:t>
-            </a:r>
-            <a:r>
-              <a:rPr lang="en-US" sz="3600" dirty="0" err="1"/>
-              <a:t>interakcj</a:t>
-            </a:r>
-            <a:r>
-              <a:rPr lang="pl-PL" sz="3600" dirty="0"/>
-              <a:t>i.</a:t>
-            </a:r>
-          </a:p>
-          <a:p>
-            <a:pPr>
-              <a:buFont typeface="Wingdings" panose="05000000000000000000" pitchFamily="2" charset="2"/>
-              <a:buChar char="§"/>
-            </a:pPr>
-            <a:endParaRPr lang="en-US" sz="3600" dirty="0"/>
-          </a:p>
-        </p:txBody>
-      </p:sp>
       <p:pic>
         <p:nvPicPr>
-          <p:cNvPr id="5" name="Obraz 4">
-            <a:extLst>
-              <a:ext uri="{FF2B5EF4-FFF2-40B4-BE49-F238E27FC236}">
-                <a16:creationId xmlns:a16="http://schemas.microsoft.com/office/drawing/2014/main" id="{B5D8E6B7-A676-19C9-FBC0-6F82629BCBDD}"/>
+          <p:cNvPr id="4" name="Obraz 3">
+            <a:extLst>
+              <a:ext uri="{FF2B5EF4-FFF2-40B4-BE49-F238E27FC236}">
+                <a16:creationId xmlns:a16="http://schemas.microsoft.com/office/drawing/2014/main" id="{D1C94B36-4188-B57F-D942-9E288C45B2A9}"/>
               </a:ext>
             </a:extLst>
           </p:cNvPr>
@@ -6454,25 +6780,84 @@
           <p:nvPr/>
         </p:nvPicPr>
         <p:blipFill>
-          <a:blip r:embed="rId2"/>
+          <a:blip r:embed="rId2">
+            <a:extLst>
+              <a:ext uri="{28A0092B-C50C-407E-A947-70E740481C1C}">
+                <a14:useLocalDpi xmlns:a14="http://schemas.microsoft.com/office/drawing/2010/main" val="0"/>
+              </a:ext>
+            </a:extLst>
+          </a:blip>
           <a:stretch>
             <a:fillRect/>
           </a:stretch>
         </p:blipFill>
         <p:spPr>
           <a:xfrm>
-            <a:off x="8549941" y="3962400"/>
-            <a:ext cx="3261175" cy="2735179"/>
+            <a:off x="2398000" y="244638"/>
+            <a:ext cx="9794000" cy="6121250"/>
           </a:xfrm>
           <a:prstGeom prst="rect">
             <a:avLst/>
           </a:prstGeom>
         </p:spPr>
       </p:pic>
+      <p:sp>
+        <p:nvSpPr>
+          <p:cNvPr id="3" name="pole tekstowe 2">
+            <a:extLst>
+              <a:ext uri="{FF2B5EF4-FFF2-40B4-BE49-F238E27FC236}">
+                <a16:creationId xmlns:a16="http://schemas.microsoft.com/office/drawing/2014/main" id="{4E702975-534F-BD40-3DB2-DC29CD0460FD}"/>
+              </a:ext>
+            </a:extLst>
+          </p:cNvPr>
+          <p:cNvSpPr txBox="1"/>
+          <p:nvPr/>
+        </p:nvSpPr>
+        <p:spPr>
+          <a:xfrm>
+            <a:off x="481262" y="5104004"/>
+            <a:ext cx="3100138" cy="1261884"/>
+          </a:xfrm>
+          <a:prstGeom prst="rect">
+            <a:avLst/>
+          </a:prstGeom>
+          <a:noFill/>
+        </p:spPr>
+        <p:txBody>
+          <a:bodyPr wrap="square" rtlCol="0" anchor="b">
+            <a:spAutoFit/>
+          </a:bodyPr>
+          <a:lstStyle/>
+          <a:p>
+            <a:r>
+              <a:rPr lang="pl-PL" sz="1900" u="sng" dirty="0"/>
+              <a:t>Parametry</a:t>
+            </a:r>
+          </a:p>
+          <a:p>
+            <a:r>
+              <a:rPr lang="pl-PL" sz="1900" dirty="0"/>
+              <a:t>liczba cech: 5</a:t>
+            </a:r>
+          </a:p>
+          <a:p>
+            <a:r>
+              <a:rPr lang="pl-PL" sz="1900" dirty="0"/>
+              <a:t>liczba wariantów: 5</a:t>
+            </a:r>
+          </a:p>
+          <a:p>
+            <a:r>
+              <a:rPr lang="pl-PL" sz="1900" dirty="0"/>
+              <a:t>liczba iteracji: &lt;1mln</a:t>
+            </a:r>
+          </a:p>
+        </p:txBody>
+      </p:sp>
     </p:spTree>
     <p:extLst>
       <p:ext uri="{BB962C8B-B14F-4D97-AF65-F5344CB8AC3E}">
-        <p14:creationId xmlns:p14="http://schemas.microsoft.com/office/powerpoint/2010/main" val="1142525123"/>
+        <p14:creationId xmlns:p14="http://schemas.microsoft.com/office/powerpoint/2010/main" val="2773652040"/>
       </p:ext>
     </p:extLst>
   </p:cSld>
@@ -6487,7 +6872,13 @@
   <p:cSld>
     <p:spTree>
       <p:nvGrpSpPr>
-        <p:cNvPr id="1" name=""/>
+        <p:cNvPr id="1" name="">
+          <a:extLst>
+            <a:ext uri="{FF2B5EF4-FFF2-40B4-BE49-F238E27FC236}">
+              <a16:creationId xmlns:a16="http://schemas.microsoft.com/office/drawing/2014/main" id="{CC6C778C-6913-9203-0009-771F46F93336}"/>
+            </a:ext>
+          </a:extLst>
+        </p:cNvPr>
         <p:cNvGrpSpPr/>
         <p:nvPr/>
       </p:nvGrpSpPr>
@@ -6499,72 +6890,93 @@
           <a:chExt cx="0" cy="0"/>
         </a:xfrm>
       </p:grpSpPr>
-      <p:sp>
-        <p:nvSpPr>
-          <p:cNvPr id="2" name="Tytuł 1">
-            <a:extLst>
-              <a:ext uri="{FF2B5EF4-FFF2-40B4-BE49-F238E27FC236}">
-                <a16:creationId xmlns:a16="http://schemas.microsoft.com/office/drawing/2014/main" id="{958507E3-A492-ADE9-9CC9-39CA0FE7FF78}"/>
-              </a:ext>
-            </a:extLst>
-          </p:cNvPr>
-          <p:cNvSpPr>
-            <a:spLocks noGrp="1"/>
-          </p:cNvSpPr>
-          <p:nvPr>
-            <p:ph type="title"/>
-          </p:nvPr>
-        </p:nvSpPr>
-        <p:spPr/>
-        <p:txBody>
-          <a:bodyPr/>
+      <p:pic>
+        <p:nvPicPr>
+          <p:cNvPr id="4" name="Obraz 3">
+            <a:extLst>
+              <a:ext uri="{FF2B5EF4-FFF2-40B4-BE49-F238E27FC236}">
+                <a16:creationId xmlns:a16="http://schemas.microsoft.com/office/drawing/2014/main" id="{0145A6B3-F51E-DF0E-0AF2-74CD15D5F1B7}"/>
+              </a:ext>
+            </a:extLst>
+          </p:cNvPr>
+          <p:cNvPicPr>
+            <a:picLocks noChangeAspect="1"/>
+          </p:cNvPicPr>
+          <p:nvPr/>
+        </p:nvPicPr>
+        <p:blipFill>
+          <a:blip r:embed="rId2">
+            <a:extLst>
+              <a:ext uri="{28A0092B-C50C-407E-A947-70E740481C1C}">
+                <a14:useLocalDpi xmlns:a14="http://schemas.microsoft.com/office/drawing/2010/main" val="0"/>
+              </a:ext>
+            </a:extLst>
+          </a:blip>
+          <a:stretch>
+            <a:fillRect/>
+          </a:stretch>
+        </p:blipFill>
+        <p:spPr>
+          <a:xfrm>
+            <a:off x="0" y="324263"/>
+            <a:ext cx="12192000" cy="4876799"/>
+          </a:xfrm>
+          <a:prstGeom prst="rect">
+            <a:avLst/>
+          </a:prstGeom>
+        </p:spPr>
+      </p:pic>
+      <p:sp>
+        <p:nvSpPr>
+          <p:cNvPr id="6" name="pole tekstowe 5">
+            <a:extLst>
+              <a:ext uri="{FF2B5EF4-FFF2-40B4-BE49-F238E27FC236}">
+                <a16:creationId xmlns:a16="http://schemas.microsoft.com/office/drawing/2014/main" id="{172743B8-D8F6-9E33-B65F-B2EE3D858D57}"/>
+              </a:ext>
+            </a:extLst>
+          </p:cNvPr>
+          <p:cNvSpPr txBox="1"/>
+          <p:nvPr/>
+        </p:nvSpPr>
+        <p:spPr>
+          <a:xfrm>
+            <a:off x="481262" y="5396392"/>
+            <a:ext cx="5213685" cy="969496"/>
+          </a:xfrm>
+          <a:prstGeom prst="rect">
+            <a:avLst/>
+          </a:prstGeom>
+          <a:noFill/>
+        </p:spPr>
+        <p:txBody>
+          <a:bodyPr wrap="square" rtlCol="0" anchor="b">
+            <a:spAutoFit/>
+          </a:bodyPr>
           <a:lstStyle/>
           <a:p>
             <a:r>
-              <a:rPr lang="pl-PL" dirty="0"/>
-              <a:t>Rezultat rozszerzenia modelu</a:t>
-            </a:r>
-            <a:endParaRPr lang="en-US" dirty="0"/>
-          </a:p>
-        </p:txBody>
-      </p:sp>
-      <p:sp>
-        <p:nvSpPr>
-          <p:cNvPr id="3" name="Symbol zastępczy zawartości 2">
-            <a:extLst>
-              <a:ext uri="{FF2B5EF4-FFF2-40B4-BE49-F238E27FC236}">
-                <a16:creationId xmlns:a16="http://schemas.microsoft.com/office/drawing/2014/main" id="{0A2EC9DE-B8DC-3284-A196-82B0FE9D5307}"/>
-              </a:ext>
-            </a:extLst>
-          </p:cNvPr>
-          <p:cNvSpPr>
-            <a:spLocks noGrp="1"/>
-          </p:cNvSpPr>
-          <p:nvPr>
-            <p:ph idx="1"/>
-          </p:nvPr>
-        </p:nvSpPr>
-        <p:spPr/>
-        <p:txBody>
-          <a:bodyPr/>
-          <a:lstStyle/>
-          <a:p>
-            <a:pPr>
-              <a:buFont typeface="Wingdings" panose="05000000000000000000" pitchFamily="2" charset="2"/>
-              <a:buChar char="§"/>
-            </a:pPr>
-            <a:r>
-              <a:rPr lang="pl-PL" dirty="0"/>
-              <a:t>Szybsze ujednolicenie poprzez posiadanie większej ilości sąsiadów.</a:t>
-            </a:r>
-            <a:endParaRPr lang="en-US" dirty="0"/>
+              <a:rPr lang="pl-PL" sz="1900" u="sng" dirty="0"/>
+              <a:t>Parametry</a:t>
+            </a:r>
+          </a:p>
+          <a:p>
+            <a:r>
+              <a:rPr lang="pl-PL" sz="1900" dirty="0"/>
+              <a:t>liczba cech: 3, liczba wariantów: 6</a:t>
+            </a:r>
+          </a:p>
+          <a:p>
+            <a:r>
+              <a:rPr lang="pl-PL" sz="1900" dirty="0"/>
+              <a:t>długość boku siatki: 18,  liczba iteracji: 1mln</a:t>
+            </a:r>
           </a:p>
         </p:txBody>
       </p:sp>
     </p:spTree>
     <p:extLst>
       <p:ext uri="{BB962C8B-B14F-4D97-AF65-F5344CB8AC3E}">
-        <p14:creationId xmlns:p14="http://schemas.microsoft.com/office/powerpoint/2010/main" val="907463827"/>
+        <p14:creationId xmlns:p14="http://schemas.microsoft.com/office/powerpoint/2010/main" val="2513979403"/>
       </p:ext>
     </p:extLst>
   </p:cSld>

</xml_diff>

<commit_message>
zamiana szansa interakcji na wyrównanie sasiedztw
</commit_message>
<xml_diff>
--- a/ModelAxelroda_prezentacja.pptx
+++ b/ModelAxelroda_prezentacja.pptx
@@ -148,10 +148,25 @@
   <pc:docChgLst>
     <pc:chgData name="Karol Garabczewski" userId="6e35707fbcbc2133" providerId="LiveId" clId="{FDA66D67-08B2-4F99-85FD-82FDE8892109}"/>
     <pc:docChg chg="undo custSel addSld delSld modSld">
-      <pc:chgData name="Karol Garabczewski" userId="6e35707fbcbc2133" providerId="LiveId" clId="{FDA66D67-08B2-4F99-85FD-82FDE8892109}" dt="2026-06-24T16:32:13.398" v="655" actId="20577"/>
+      <pc:chgData name="Karol Garabczewski" userId="6e35707fbcbc2133" providerId="LiveId" clId="{FDA66D67-08B2-4F99-85FD-82FDE8892109}" dt="2026-06-25T08:57:06.004" v="667" actId="20577"/>
       <pc:docMkLst>
         <pc:docMk/>
       </pc:docMkLst>
+      <pc:sldChg chg="modSp mod">
+        <pc:chgData name="Karol Garabczewski" userId="6e35707fbcbc2133" providerId="LiveId" clId="{FDA66D67-08B2-4F99-85FD-82FDE8892109}" dt="2026-06-25T08:57:06.004" v="667" actId="20577"/>
+        <pc:sldMkLst>
+          <pc:docMk/>
+          <pc:sldMk cId="1142525123" sldId="263"/>
+        </pc:sldMkLst>
+        <pc:spChg chg="mod">
+          <ac:chgData name="Karol Garabczewski" userId="6e35707fbcbc2133" providerId="LiveId" clId="{FDA66D67-08B2-4F99-85FD-82FDE8892109}" dt="2026-06-25T08:57:06.004" v="667" actId="20577"/>
+          <ac:spMkLst>
+            <pc:docMk/>
+            <pc:sldMk cId="1142525123" sldId="263"/>
+            <ac:spMk id="3" creationId="{BA4F3297-7DD6-0EF4-82F1-773AB2F43F61}"/>
+          </ac:spMkLst>
+        </pc:spChg>
+      </pc:sldChg>
       <pc:sldChg chg="addSp delSp modSp new mod">
         <pc:chgData name="Karol Garabczewski" userId="6e35707fbcbc2133" providerId="LiveId" clId="{FDA66D67-08B2-4F99-85FD-82FDE8892109}" dt="2026-06-24T16:27:39.748" v="568" actId="20577"/>
         <pc:sldMkLst>
@@ -896,7 +911,7 @@
           <a:p>
             <a:fld id="{21FD153F-C2D7-42B8-9DDD-313149076134}" type="datetimeFigureOut">
               <a:rPr lang="pl-PL" smtClean="0"/>
-              <a:t>24.06.2026</a:t>
+              <a:t>25.06.2026</a:t>
             </a:fld>
             <a:endParaRPr lang="pl-PL"/>
           </a:p>
@@ -1312,7 +1327,7 @@
           <a:p>
             <a:fld id="{CC219924-E421-45AF-95F8-DE961D4F9D7A}" type="datetime1">
               <a:rPr lang="en-US" smtClean="0"/>
-              <a:t>6/24/2026</a:t>
+              <a:t>6/25/2026</a:t>
             </a:fld>
             <a:endParaRPr lang="en-US"/>
           </a:p>
@@ -1512,7 +1527,7 @@
           <a:p>
             <a:fld id="{F11651D3-EEA5-4503-81CA-84DD957BCB36}" type="datetime1">
               <a:rPr lang="en-US" smtClean="0"/>
-              <a:t>6/24/2026</a:t>
+              <a:t>6/25/2026</a:t>
             </a:fld>
             <a:endParaRPr lang="en-US"/>
           </a:p>
@@ -1722,7 +1737,7 @@
           <a:p>
             <a:fld id="{DAF250FE-9038-48B6-94F3-ECFC677205F2}" type="datetime1">
               <a:rPr lang="en-US" smtClean="0"/>
-              <a:t>6/24/2026</a:t>
+              <a:t>6/25/2026</a:t>
             </a:fld>
             <a:endParaRPr lang="en-US"/>
           </a:p>
@@ -1922,7 +1937,7 @@
           <a:p>
             <a:fld id="{06BFBEC8-DC87-4AD6-A3C0-88B93FFD0D13}" type="datetime1">
               <a:rPr lang="en-US" smtClean="0"/>
-              <a:t>6/24/2026</a:t>
+              <a:t>6/25/2026</a:t>
             </a:fld>
             <a:endParaRPr lang="en-US"/>
           </a:p>
@@ -2198,7 +2213,7 @@
           <a:p>
             <a:fld id="{80B419C0-543D-4075-9507-412CBCC30423}" type="datetime1">
               <a:rPr lang="en-US" smtClean="0"/>
-              <a:t>6/24/2026</a:t>
+              <a:t>6/25/2026</a:t>
             </a:fld>
             <a:endParaRPr lang="en-US"/>
           </a:p>
@@ -2466,7 +2481,7 @@
           <a:p>
             <a:fld id="{0535CA57-FCE8-44E1-A5F0-E29C2B2639B4}" type="datetime1">
               <a:rPr lang="en-US" smtClean="0"/>
-              <a:t>6/24/2026</a:t>
+              <a:t>6/25/2026</a:t>
             </a:fld>
             <a:endParaRPr lang="en-US"/>
           </a:p>
@@ -2881,7 +2896,7 @@
           <a:p>
             <a:fld id="{BA2CBAD6-0278-49CE-A1D5-416981DF7CE4}" type="datetime1">
               <a:rPr lang="en-US" smtClean="0"/>
-              <a:t>6/24/2026</a:t>
+              <a:t>6/25/2026</a:t>
             </a:fld>
             <a:endParaRPr lang="en-US"/>
           </a:p>
@@ -3023,7 +3038,7 @@
           <a:p>
             <a:fld id="{C511A707-D6C6-4D3D-9AB3-F062F184410C}" type="datetime1">
               <a:rPr lang="en-US" smtClean="0"/>
-              <a:t>6/24/2026</a:t>
+              <a:t>6/25/2026</a:t>
             </a:fld>
             <a:endParaRPr lang="en-US"/>
           </a:p>
@@ -3136,7 +3151,7 @@
           <a:p>
             <a:fld id="{F19F0C89-A7E6-4C5B-B3BD-10DCFD7050F3}" type="datetime1">
               <a:rPr lang="en-US" smtClean="0"/>
-              <a:t>6/24/2026</a:t>
+              <a:t>6/25/2026</a:t>
             </a:fld>
             <a:endParaRPr lang="en-US"/>
           </a:p>
@@ -3449,7 +3464,7 @@
           <a:p>
             <a:fld id="{AD206A01-47A2-4797-B056-F939721E8BB4}" type="datetime1">
               <a:rPr lang="en-US" smtClean="0"/>
-              <a:t>6/24/2026</a:t>
+              <a:t>6/25/2026</a:t>
             </a:fld>
             <a:endParaRPr lang="en-US"/>
           </a:p>
@@ -3738,7 +3753,7 @@
           <a:p>
             <a:fld id="{8800C9F3-23E9-41A3-A86F-F642FAA31D8A}" type="datetime1">
               <a:rPr lang="en-US" smtClean="0"/>
-              <a:t>6/24/2026</a:t>
+              <a:t>6/25/2026</a:t>
             </a:fld>
             <a:endParaRPr lang="en-US"/>
           </a:p>
@@ -3981,7 +3996,7 @@
           <a:p>
             <a:fld id="{794C5B19-86B2-4997-B0CD-299D1D03B03B}" type="datetime1">
               <a:rPr lang="en-US" smtClean="0"/>
-              <a:t>6/24/2026</a:t>
+              <a:t>6/25/2026</a:t>
             </a:fld>
             <a:endParaRPr lang="en-US"/>
           </a:p>
@@ -6356,25 +6371,10 @@
               <a:t>równując</a:t>
             </a:r>
             <a:r>
-              <a:rPr lang="en-US" sz="3600" dirty="0"/>
-              <a:t> </a:t>
-            </a:r>
-            <a:r>
-              <a:rPr lang="en-US" sz="3600" dirty="0" err="1"/>
-              <a:t>szanse</a:t>
-            </a:r>
-            <a:r>
-              <a:rPr lang="en-US" sz="3600" dirty="0"/>
-              <a:t> </a:t>
-            </a:r>
-            <a:r>
-              <a:rPr lang="en-US" sz="3600" dirty="0" err="1"/>
-              <a:t>interakcj</a:t>
-            </a:r>
-            <a:r>
-              <a:rPr lang="pl-PL" sz="3600" dirty="0"/>
-              <a:t>i.</a:t>
-            </a:r>
+              <a:rPr lang="pl-PL" sz="3600"/>
+              <a:t> sąsiedztwa.</a:t>
+            </a:r>
+            <a:endParaRPr lang="pl-PL" sz="3600" dirty="0"/>
           </a:p>
           <a:p>
             <a:pPr>

</xml_diff>